<commit_message>
docs: mettre à jour la présentation finale
</commit_message>
<xml_diff>
--- a/livrables/présentation/HomeSkolar_Presentation_Validation_Cadrage.pptx
+++ b/livrables/présentation/HomeSkolar_Presentation_Validation_Cadrage.pptx
@@ -700,7 +700,7 @@
           <a:lstStyle xmlns:a="http://schemas.openxmlformats.org/drawingml/2006/main"/>
           <a:p xmlns:a="http://schemas.openxmlformats.org/drawingml/2006/main">
             <a:r>
-              <a:t>HomeSkolar est une association qui rapproche des enfants en difficulté scolaire et des tuteurs bénévoles.</a:t>
+              <a:t>HomeSkolar est une association qui rapproche des élèves en difficulté scolaire et des tuteurs bénévoles.</a:t>
             </a:r>
           </a:p>
           <a:p xmlns:a="http://schemas.openxmlformats.org/drawingml/2006/main">
@@ -860,7 +860,7 @@
           <a:lstStyle xmlns:a="http://schemas.openxmlformats.org/drawingml/2006/main"/>
           <a:p xmlns:a="http://schemas.openxmlformats.org/drawingml/2006/main">
             <a:r>
-              <a:t>Le parcours commence par le compte, puis l’affectation du tuteur. Ces deux étapes rendent possibles les trois domaines de suivi.</a:t>
+              <a:t>Le parcours commence par le compte, puis l’affectation d’un tuteur disponible. Si aucun tuteur n’est disponible, l’élève reste en attente et en est informé. Ces deux étapes rendent possibles les trois domaines de suivi.</a:t>
             </a:r>
           </a:p>
           <a:p xmlns:a="http://schemas.openxmlformats.org/drawingml/2006/main">
@@ -940,12 +940,12 @@
           <a:lstStyle xmlns:a="http://schemas.openxmlformats.org/drawingml/2006/main"/>
           <a:p xmlns:a="http://schemas.openxmlformats.org/drawingml/2006/main">
             <a:r>
-              <a:t>L’architecture retenue est un monolithe Django.</a:t>
-            </a:r>
-          </a:p>
-          <a:p xmlns:a="http://schemas.openxmlformats.org/drawingml/2006/main">
-            <a:r>
-              <a:t>Le navigateur reçoit des pages rendues par les gabarits Django et mises en forme avec Bootstrap. Django porte les règles métier, l’authentification et les autorisations. PostgreSQL assure la persistance.</a:t>
+              <a:t>L’architecture retenue est un monolithe Python 3.14 avec Django 5.2 LTS.</a:t>
+            </a:r>
+          </a:p>
+          <a:p xmlns:a="http://schemas.openxmlformats.org/drawingml/2006/main">
+            <a:r>
+              <a:t>Le navigateur reçoit des pages rendues par les gabarits Django et mises en forme avec Bootstrap. Django porte les règles métier, l’authentification et les autorisations. PostgreSQL 17 assure la persistance.</a:t>
             </a:r>
           </a:p>
           <a:p xmlns:a="http://schemas.openxmlformats.org/drawingml/2006/main">
@@ -2702,7 +2702,7 @@
                 <a:ea typeface="Arial"/>
                 <a:cs typeface="Arial"/>
               </a:rPr>
-              <a:t>Deux acteurs et cinq domaines fonctionnels, sans fonctions périphériques.</a:t>
+              <a:t>Deux acteurs et quatre grands usages, sans fonctions périphériques.</a:t>
             </a:r>
           </a:p>
         </p:txBody>
@@ -3551,7 +3551,7 @@
                 <a:ea typeface="Arial"/>
                 <a:cs typeface="Arial"/>
               </a:rPr>
-              <a:t>Mettre en relation des enfants en difficulté scolaire avec des tuteurs bénévoles, puis faciliter leur suivi au quotidien.</a:t>
+              <a:t>Mettre en relation des élèves en difficulté scolaire avec des tuteurs bénévoles, puis faciliter leur suivi au quotidien.</a:t>
             </a:r>
           </a:p>
         </p:txBody>
@@ -4050,7 +4050,7 @@
                 <a:ea typeface="Arial"/>
                 <a:cs typeface="Arial"/>
               </a:rPr>
-              <a:t>Source : cahier des charges HomeSkolar v3.0 · contexte de mission</a:t>
+              <a:t>Source : cahier des charges HomeSkolar v3.1 · contexte de mission</a:t>
             </a:r>
           </a:p>
         </p:txBody>
@@ -4520,7 +4520,7 @@
                 <a:ea typeface="Arial"/>
                 <a:cs typeface="Arial"/>
               </a:rPr>
-              <a:t>S’inscrire librement, se connecter et associer automatiquement un élève à un tuteur.</a:t>
+              <a:t>S’inscrire librement, se connecter et associer automatiquement un élève à un tuteur disponible.</a:t>
             </a:r>
           </a:p>
         </p:txBody>
@@ -5100,7 +5100,7 @@
                 <a:ea typeface="Arial"/>
                 <a:cs typeface="Arial"/>
               </a:rPr>
-              <a:t>Source : spécifications fonctionnelles HomeSkolar v3.0</a:t>
+              <a:t>Source : spécifications fonctionnelles HomeSkolar v3.1</a:t>
             </a:r>
           </a:p>
         </p:txBody>
@@ -5819,7 +5819,7 @@
                 <a:ea typeface="Arial"/>
                 <a:cs typeface="Arial"/>
               </a:rPr>
-              <a:t>un tuteur</a:t>
+              <a:t>un tuteur disponible</a:t>
             </a:r>
           </a:p>
         </p:txBody>
@@ -6857,7 +6857,7 @@
                 <a:ea typeface="Arial"/>
                 <a:cs typeface="Arial"/>
               </a:rPr>
-              <a:t>Bootstrap 5.3</a:t>
+              <a:t>Bootstrap 5.3.x</a:t>
             </a:r>
           </a:p>
         </p:txBody>
@@ -6915,7 +6915,7 @@
                 <a:ea typeface="Arial"/>
                 <a:cs typeface="Arial"/>
               </a:rPr>
-              <a:t>Django 5.2 LTS</a:t>
+              <a:t>Python 3.14 · Django 5.2 LTS</a:t>
             </a:r>
           </a:p>
         </p:txBody>
@@ -7077,7 +7077,7 @@
                 <a:ea typeface="Arial"/>
                 <a:cs typeface="Arial"/>
               </a:rPr>
-              <a:t>PostgreSQL</a:t>
+              <a:t>PostgreSQL 17</a:t>
             </a:r>
           </a:p>
         </p:txBody>
@@ -7307,7 +7307,7 @@
                 <a:ea typeface="Arial"/>
                 <a:cs typeface="Arial"/>
               </a:rPr>
-              <a:t>Source : spécifications techniques HomeSkolar v3.0</a:t>
+              <a:t>Source : spécifications techniques HomeSkolar v3.1</a:t>
             </a:r>
           </a:p>
         </p:txBody>
@@ -7746,7 +7746,7 @@
                 <a:ea typeface="Arial"/>
                 <a:cs typeface="Arial"/>
               </a:rPr>
-              <a:t>Django + gabarits</a:t>
+              <a:t>Python 3.14 · Django 5.2 LTS</a:t>
             </a:r>
           </a:p>
           <a:p xmlns:a="http://schemas.openxmlformats.org/drawingml/2006/main">
@@ -7769,7 +7769,7 @@
                 <a:ea typeface="Arial"/>
                 <a:cs typeface="Arial"/>
               </a:rPr>
-              <a:t>Bootstrap responsive</a:t>
+              <a:t>Bootstrap 5.3.x</a:t>
             </a:r>
           </a:p>
           <a:p xmlns:a="http://schemas.openxmlformats.org/drawingml/2006/main">
@@ -7792,7 +7792,7 @@
                 <a:ea typeface="Arial"/>
                 <a:cs typeface="Arial"/>
               </a:rPr>
-              <a:t>PostgreSQL</a:t>
+              <a:t>PostgreSQL 17</a:t>
             </a:r>
           </a:p>
         </p:txBody>
@@ -8441,7 +8441,7 @@
                 <a:ea typeface="Arial"/>
                 <a:cs typeface="Arial"/>
               </a:rPr>
-              <a:t>Source : veille technologique et spécifications techniques HomeSkolar v3.0</a:t>
+              <a:t>Source : veille technologique et spécifications techniques HomeSkolar v3.1</a:t>
             </a:r>
           </a:p>
         </p:txBody>

</xml_diff>